<commit_message>
small updates to the slide deck
</commit_message>
<xml_diff>
--- a/resources/Thermal_loop_data/Thermal Loop Data Graphs.pptx
+++ b/resources/Thermal_loop_data/Thermal Loop Data Graphs.pptx
@@ -4598,7 +4598,7 @@
               <a:buChar char="-"/>
             </a:pPr>
             <a:r>
-              <a:rPr lang="en-US"/>
+              <a:rPr lang="en-US" dirty="0"/>
               <a:t>Middle valve open</a:t>
             </a:r>
           </a:p>
@@ -4608,7 +4608,7 @@
               <a:buChar char="-"/>
             </a:pPr>
             <a:r>
-              <a:rPr lang="en-US"/>
+              <a:rPr lang="en-US" dirty="0"/>
               <a:t>Upper valve open</a:t>
             </a:r>
           </a:p>
@@ -4618,7 +4618,7 @@
               <a:buChar char="-"/>
             </a:pPr>
             <a:r>
-              <a:rPr lang="en-US"/>
+              <a:rPr lang="en-US" dirty="0"/>
               <a:t>Heat exchange increments of 0.5 gal/min</a:t>
             </a:r>
           </a:p>
@@ -4670,14 +4670,22 @@
             <p:ph type="ctrTitle"/>
           </p:nvPr>
         </p:nvSpPr>
-        <p:spPr/>
-        <p:txBody>
-          <a:bodyPr/>
-          <a:lstStyle/>
-          <a:p>
-            <a:r>
-              <a:rPr lang="en-US"/>
-              <a:t>6-hour pump heat up</a:t>
+        <p:spPr>
+          <a:xfrm>
+            <a:off x="838200" y="415577"/>
+            <a:ext cx="9144000" cy="941827"/>
+          </a:xfrm>
+        </p:spPr>
+        <p:txBody>
+          <a:bodyPr>
+            <a:normAutofit fontScale="90000"/>
+          </a:bodyPr>
+          <a:lstStyle/>
+          <a:p>
+            <a:pPr algn="l"/>
+            <a:r>
+              <a:rPr lang="en-US" dirty="0"/>
+              <a:t>Test #1: 6-hour pump heat up</a:t>
             </a:r>
           </a:p>
         </p:txBody>
@@ -4698,7 +4706,12 @@
             <p:ph type="subTitle" idx="1"/>
           </p:nvPr>
         </p:nvSpPr>
-        <p:spPr/>
+        <p:spPr>
+          <a:xfrm>
+            <a:off x="-1042219" y="5460335"/>
+            <a:ext cx="9144000" cy="1655762"/>
+          </a:xfrm>
+        </p:spPr>
         <p:txBody>
           <a:bodyPr vert="horz" lIns="91440" tIns="45720" rIns="91440" bIns="45720" rtlCol="0" anchor="t">
             <a:normAutofit/>
@@ -4715,6 +4728,259 @@
           </a:p>
         </p:txBody>
       </p:sp>
+      <p:sp>
+        <p:nvSpPr>
+          <p:cNvPr id="5" name="Content Placeholder 2">
+            <a:extLst>
+              <a:ext uri="{FF2B5EF4-FFF2-40B4-BE49-F238E27FC236}">
+                <a16:creationId xmlns:a16="http://schemas.microsoft.com/office/drawing/2014/main" id="{7753F99E-0896-43BA-739A-5E4CC5A08380}"/>
+              </a:ext>
+            </a:extLst>
+          </p:cNvPr>
+          <p:cNvSpPr txBox="1">
+            <a:spLocks/>
+          </p:cNvSpPr>
+          <p:nvPr/>
+        </p:nvSpPr>
+        <p:spPr>
+          <a:xfrm>
+            <a:off x="838200" y="1825625"/>
+            <a:ext cx="4702521" cy="4351338"/>
+          </a:xfrm>
+          <a:prstGeom prst="rect">
+            <a:avLst/>
+          </a:prstGeom>
+        </p:spPr>
+        <p:txBody>
+          <a:bodyPr vert="horz" lIns="91440" tIns="45720" rIns="91440" bIns="45720" rtlCol="0" anchor="t">
+            <a:normAutofit/>
+          </a:bodyPr>
+          <a:lstStyle>
+            <a:lvl1pPr marL="0" indent="0" algn="ctr" defTabSz="914400" rtl="0" eaLnBrk="1" latinLnBrk="0" hangingPunct="1">
+              <a:lnSpc>
+                <a:spcPct val="90000"/>
+              </a:lnSpc>
+              <a:spcBef>
+                <a:spcPts val="1000"/>
+              </a:spcBef>
+              <a:buFont typeface="Arial" panose="020B0604020202020204" pitchFamily="34" charset="0"/>
+              <a:buNone/>
+              <a:defRPr sz="2400" kern="1200">
+                <a:solidFill>
+                  <a:schemeClr val="tx1"/>
+                </a:solidFill>
+                <a:latin typeface="+mn-lt"/>
+                <a:ea typeface="+mn-ea"/>
+                <a:cs typeface="+mn-cs"/>
+              </a:defRPr>
+            </a:lvl1pPr>
+            <a:lvl2pPr marL="457200" indent="0" algn="ctr" defTabSz="914400" rtl="0" eaLnBrk="1" latinLnBrk="0" hangingPunct="1">
+              <a:lnSpc>
+                <a:spcPct val="90000"/>
+              </a:lnSpc>
+              <a:spcBef>
+                <a:spcPts val="500"/>
+              </a:spcBef>
+              <a:buFont typeface="Arial" panose="020B0604020202020204" pitchFamily="34" charset="0"/>
+              <a:buNone/>
+              <a:defRPr sz="2000" kern="1200">
+                <a:solidFill>
+                  <a:schemeClr val="tx1"/>
+                </a:solidFill>
+                <a:latin typeface="+mn-lt"/>
+                <a:ea typeface="+mn-ea"/>
+                <a:cs typeface="+mn-cs"/>
+              </a:defRPr>
+            </a:lvl2pPr>
+            <a:lvl3pPr marL="914400" indent="0" algn="ctr" defTabSz="914400" rtl="0" eaLnBrk="1" latinLnBrk="0" hangingPunct="1">
+              <a:lnSpc>
+                <a:spcPct val="90000"/>
+              </a:lnSpc>
+              <a:spcBef>
+                <a:spcPts val="500"/>
+              </a:spcBef>
+              <a:buFont typeface="Arial" panose="020B0604020202020204" pitchFamily="34" charset="0"/>
+              <a:buNone/>
+              <a:defRPr sz="1800" kern="1200">
+                <a:solidFill>
+                  <a:schemeClr val="tx1"/>
+                </a:solidFill>
+                <a:latin typeface="+mn-lt"/>
+                <a:ea typeface="+mn-ea"/>
+                <a:cs typeface="+mn-cs"/>
+              </a:defRPr>
+            </a:lvl3pPr>
+            <a:lvl4pPr marL="1371600" indent="0" algn="ctr" defTabSz="914400" rtl="0" eaLnBrk="1" latinLnBrk="0" hangingPunct="1">
+              <a:lnSpc>
+                <a:spcPct val="90000"/>
+              </a:lnSpc>
+              <a:spcBef>
+                <a:spcPts val="500"/>
+              </a:spcBef>
+              <a:buFont typeface="Arial" panose="020B0604020202020204" pitchFamily="34" charset="0"/>
+              <a:buNone/>
+              <a:defRPr sz="1600" kern="1200">
+                <a:solidFill>
+                  <a:schemeClr val="tx1"/>
+                </a:solidFill>
+                <a:latin typeface="+mn-lt"/>
+                <a:ea typeface="+mn-ea"/>
+                <a:cs typeface="+mn-cs"/>
+              </a:defRPr>
+            </a:lvl4pPr>
+            <a:lvl5pPr marL="1828800" indent="0" algn="ctr" defTabSz="914400" rtl="0" eaLnBrk="1" latinLnBrk="0" hangingPunct="1">
+              <a:lnSpc>
+                <a:spcPct val="90000"/>
+              </a:lnSpc>
+              <a:spcBef>
+                <a:spcPts val="500"/>
+              </a:spcBef>
+              <a:buFont typeface="Arial" panose="020B0604020202020204" pitchFamily="34" charset="0"/>
+              <a:buNone/>
+              <a:defRPr sz="1600" kern="1200">
+                <a:solidFill>
+                  <a:schemeClr val="tx1"/>
+                </a:solidFill>
+                <a:latin typeface="+mn-lt"/>
+                <a:ea typeface="+mn-ea"/>
+                <a:cs typeface="+mn-cs"/>
+              </a:defRPr>
+            </a:lvl5pPr>
+            <a:lvl6pPr marL="2286000" indent="0" algn="ctr" defTabSz="914400" rtl="0" eaLnBrk="1" latinLnBrk="0" hangingPunct="1">
+              <a:lnSpc>
+                <a:spcPct val="90000"/>
+              </a:lnSpc>
+              <a:spcBef>
+                <a:spcPts val="500"/>
+              </a:spcBef>
+              <a:buFont typeface="Arial" panose="020B0604020202020204" pitchFamily="34" charset="0"/>
+              <a:buNone/>
+              <a:defRPr sz="1600" kern="1200">
+                <a:solidFill>
+                  <a:schemeClr val="tx1"/>
+                </a:solidFill>
+                <a:latin typeface="+mn-lt"/>
+                <a:ea typeface="+mn-ea"/>
+                <a:cs typeface="+mn-cs"/>
+              </a:defRPr>
+            </a:lvl6pPr>
+            <a:lvl7pPr marL="2743200" indent="0" algn="ctr" defTabSz="914400" rtl="0" eaLnBrk="1" latinLnBrk="0" hangingPunct="1">
+              <a:lnSpc>
+                <a:spcPct val="90000"/>
+              </a:lnSpc>
+              <a:spcBef>
+                <a:spcPts val="500"/>
+              </a:spcBef>
+              <a:buFont typeface="Arial" panose="020B0604020202020204" pitchFamily="34" charset="0"/>
+              <a:buNone/>
+              <a:defRPr sz="1600" kern="1200">
+                <a:solidFill>
+                  <a:schemeClr val="tx1"/>
+                </a:solidFill>
+                <a:latin typeface="+mn-lt"/>
+                <a:ea typeface="+mn-ea"/>
+                <a:cs typeface="+mn-cs"/>
+              </a:defRPr>
+            </a:lvl7pPr>
+            <a:lvl8pPr marL="3200400" indent="0" algn="ctr" defTabSz="914400" rtl="0" eaLnBrk="1" latinLnBrk="0" hangingPunct="1">
+              <a:lnSpc>
+                <a:spcPct val="90000"/>
+              </a:lnSpc>
+              <a:spcBef>
+                <a:spcPts val="500"/>
+              </a:spcBef>
+              <a:buFont typeface="Arial" panose="020B0604020202020204" pitchFamily="34" charset="0"/>
+              <a:buNone/>
+              <a:defRPr sz="1600" kern="1200">
+                <a:solidFill>
+                  <a:schemeClr val="tx1"/>
+                </a:solidFill>
+                <a:latin typeface="+mn-lt"/>
+                <a:ea typeface="+mn-ea"/>
+                <a:cs typeface="+mn-cs"/>
+              </a:defRPr>
+            </a:lvl8pPr>
+            <a:lvl9pPr marL="3657600" indent="0" algn="ctr" defTabSz="914400" rtl="0" eaLnBrk="1" latinLnBrk="0" hangingPunct="1">
+              <a:lnSpc>
+                <a:spcPct val="90000"/>
+              </a:lnSpc>
+              <a:spcBef>
+                <a:spcPts val="500"/>
+              </a:spcBef>
+              <a:buFont typeface="Arial" panose="020B0604020202020204" pitchFamily="34" charset="0"/>
+              <a:buNone/>
+              <a:defRPr sz="1600" kern="1200">
+                <a:solidFill>
+                  <a:schemeClr val="tx1"/>
+                </a:solidFill>
+                <a:latin typeface="+mn-lt"/>
+                <a:ea typeface="+mn-ea"/>
+                <a:cs typeface="+mn-cs"/>
+              </a:defRPr>
+            </a:lvl9pPr>
+          </a:lstStyle>
+          <a:p>
+            <a:pPr marL="342900" indent="-342900" algn="l">
+              <a:buFont typeface="Arial" panose="020B0604020202020204" pitchFamily="34" charset="0"/>
+              <a:buChar char="•"/>
+            </a:pPr>
+            <a:r>
+              <a:rPr lang="en-US" dirty="0"/>
+              <a:t>Middle valve open</a:t>
+            </a:r>
+          </a:p>
+          <a:p>
+            <a:pPr marL="342900" indent="-342900" algn="l">
+              <a:buFont typeface="Arial" panose="020B0604020202020204" pitchFamily="34" charset="0"/>
+              <a:buChar char="•"/>
+            </a:pPr>
+            <a:r>
+              <a:rPr lang="en-US" dirty="0"/>
+              <a:t>Upper valve open</a:t>
+            </a:r>
+          </a:p>
+          <a:p>
+            <a:pPr marL="342900" indent="-342900" algn="l">
+              <a:buFont typeface="Arial" panose="020B0604020202020204" pitchFamily="34" charset="0"/>
+              <a:buChar char="•"/>
+            </a:pPr>
+            <a:r>
+              <a:rPr lang="en-US" dirty="0"/>
+              <a:t>Heat exchange increments of 0.5 gal/min</a:t>
+            </a:r>
+          </a:p>
+        </p:txBody>
+      </p:sp>
+      <p:pic>
+        <p:nvPicPr>
+          <p:cNvPr id="6" name="Picture 5" descr="A graph of a temperature&#10;&#10;AI-generated content may be incorrect.">
+            <a:extLst>
+              <a:ext uri="{FF2B5EF4-FFF2-40B4-BE49-F238E27FC236}">
+                <a16:creationId xmlns:a16="http://schemas.microsoft.com/office/drawing/2014/main" id="{954AFF80-188C-AF7F-BFF2-18DB14683BCA}"/>
+              </a:ext>
+            </a:extLst>
+          </p:cNvPr>
+          <p:cNvPicPr>
+            <a:picLocks noChangeAspect="1"/>
+          </p:cNvPicPr>
+          <p:nvPr/>
+        </p:nvPicPr>
+        <p:blipFill>
+          <a:blip r:embed="rId3"/>
+          <a:stretch>
+            <a:fillRect/>
+          </a:stretch>
+        </p:blipFill>
+        <p:spPr>
+          <a:xfrm>
+            <a:off x="5776111" y="1363517"/>
+            <a:ext cx="5930019" cy="3883225"/>
+          </a:xfrm>
+          <a:prstGeom prst="rect">
+            <a:avLst/>
+          </a:prstGeom>
+        </p:spPr>
+      </p:pic>
     </p:spTree>
     <p:extLst>
       <p:ext uri="{BB962C8B-B14F-4D97-AF65-F5344CB8AC3E}">
@@ -4745,12 +5011,66 @@
           <a:chExt cx="0" cy="0"/>
         </a:xfrm>
       </p:grpSpPr>
+      <p:sp>
+        <p:nvSpPr>
+          <p:cNvPr id="3" name="Title 1">
+            <a:extLst>
+              <a:ext uri="{FF2B5EF4-FFF2-40B4-BE49-F238E27FC236}">
+                <a16:creationId xmlns:a16="http://schemas.microsoft.com/office/drawing/2014/main" id="{2C478BE5-06DD-42AD-ED22-AA822C3994B7}"/>
+              </a:ext>
+            </a:extLst>
+          </p:cNvPr>
+          <p:cNvSpPr txBox="1">
+            <a:spLocks/>
+          </p:cNvSpPr>
+          <p:nvPr/>
+        </p:nvSpPr>
+        <p:spPr>
+          <a:xfrm>
+            <a:off x="838200" y="415577"/>
+            <a:ext cx="9144000" cy="941827"/>
+          </a:xfrm>
+          <a:prstGeom prst="rect">
+            <a:avLst/>
+          </a:prstGeom>
+        </p:spPr>
+        <p:txBody>
+          <a:bodyPr>
+            <a:normAutofit fontScale="97500"/>
+          </a:bodyPr>
+          <a:lstStyle>
+            <a:lvl1pPr algn="l" defTabSz="914400" rtl="0" eaLnBrk="1" latinLnBrk="0" hangingPunct="1">
+              <a:lnSpc>
+                <a:spcPct val="90000"/>
+              </a:lnSpc>
+              <a:spcBef>
+                <a:spcPct val="0"/>
+              </a:spcBef>
+              <a:buNone/>
+              <a:defRPr sz="4400" kern="1200">
+                <a:solidFill>
+                  <a:schemeClr val="tx1"/>
+                </a:solidFill>
+                <a:latin typeface="+mj-lt"/>
+                <a:ea typeface="+mj-ea"/>
+                <a:cs typeface="+mj-cs"/>
+              </a:defRPr>
+            </a:lvl1pPr>
+          </a:lstStyle>
+          <a:p>
+            <a:r>
+              <a:rPr lang="en-US" dirty="0"/>
+              <a:t>Test #1: Additional Slide</a:t>
+            </a:r>
+          </a:p>
+        </p:txBody>
+      </p:sp>
       <p:pic>
         <p:nvPicPr>
-          <p:cNvPr id="2" name="Picture 1" descr="A graph of a temperature&#10;&#10;AI-generated content may be incorrect.">
+          <p:cNvPr id="4" name="Picture 3" descr="A graph of a temperature&#10;&#10;AI-generated content may be incorrect.">
             <a:extLst>
               <a:ext uri="{FF2B5EF4-FFF2-40B4-BE49-F238E27FC236}">
-                <a16:creationId xmlns:a16="http://schemas.microsoft.com/office/drawing/2014/main" id="{DECCEA62-6FD4-7FAC-BE7B-36040B266B5A}"/>
+                <a16:creationId xmlns:a16="http://schemas.microsoft.com/office/drawing/2014/main" id="{F0E7EDE5-FEE4-C0D4-EA4E-2BCB3CA63447}"/>
               </a:ext>
             </a:extLst>
           </p:cNvPr>
@@ -4767,8 +5087,8 @@
         </p:blipFill>
         <p:spPr>
           <a:xfrm>
-            <a:off x="881062" y="0"/>
-            <a:ext cx="10429875" cy="6858000"/>
+            <a:off x="5884239" y="1648632"/>
+            <a:ext cx="6066141" cy="3988696"/>
           </a:xfrm>
           <a:prstGeom prst="rect">
             <a:avLst/>
@@ -4930,8 +5250,8 @@
         </p:blipFill>
         <p:spPr>
           <a:xfrm>
-            <a:off x="904609" y="0"/>
-            <a:ext cx="10382782" cy="6858000"/>
+            <a:off x="805758" y="-1"/>
+            <a:ext cx="10481633" cy="6923293"/>
           </a:xfrm>
           <a:prstGeom prst="rect">
             <a:avLst/>

</xml_diff>